<commit_message>
docs: rebuild demo around the differentiated power-10
The demo previously leaned on textbook flow checks (broad-catch, unchecked-cast,
null-deref) that SonarQube/PMD already do. Rebuilt it around the rules standard
linters miss:

- examples/java/PaymentGateway.java now demonstrates 5 such rules (typestate
  builder-terminal-before-setters, guarded-by-lock-held, blocking-call-while-
  holding-lock, pure-method-no-side-effects, lambda-captures-mutable-state);
  java-fixed repairs them -> 0.
- demo/NOTES.md (MARP deck) leads with the differentiated ten and shows five
  real backend-connectors findings, headlined by a genuine atomic-get-set-race
  (textBB.set(textBB.get()...)) in DefaultStrategy. Rendered pdf/html/pptx.
- README hook swapped to the atomic race (real differentiator vs resource-leak
  which SonarQube also catches); WALKTHROUGH rewritten for the five.

Co-Authored-By: Claude Opus 4.8 (1M context) <noreply@anthropic.com>
</commit_message>
<xml_diff>
--- a/demo/NOTES.pptx
+++ b/demo/NOTES.pptx
@@ -517,11 +517,11 @@
           <a:p>
             <a:r>
               <a:rPr lang="en-US" dirty="0"/>
-              <a:t>~7 min demo. Setup off-screen:
+              <a:t>~7 min. Setup off-screen:
   cd ~/workspace/experiments/rule-smith &amp;&amp; source .venv/bin/activate
   BC=~/Desktop/clones/backend-connectors
-  TEN=resource-leak,optional-get-without-ispresent,null-deref-needs-dominating-guard,unchecked-downcast,field-read-before-assign,non-atomic-shared-update,guarded-by-lock-held,no-string-concat-in-loop,no-superfluous-else,constructor-definite-assignment
-Record a fallback video of the `add` beat (calls claude -p, network-dependent).</a:t>
+  FIVE=builder-terminal-before-setters,pure-method-no-side-effects,guarded-by-lock-held,blocking-call-while-holding-lock,lambda-captures-mutable-state
+Record a fallback video of the `add` beat (calls claude -p).</a:t>
             </a:r>
             <a:endParaRPr lang="en-US" dirty="0"/>
           </a:p>
@@ -609,9 +609,7 @@
           <a:p>
             <a:r>
               <a:rPr lang="en-US" dirty="0"/>
-              <a:t>Beat 6, 90s. Whole-repo proof: 1242 files, 0 parse errors. These five are
-representative. Next five slides: one per file. Use --rules &lt;id&gt; to isolate one
-check per slide if you want to drill in.</a:t>
+              <a:t>Beat 6, 90s. Five real findings, one per slide. The atomic race already shown is the headliner.</a:t>
             </a:r>
             <a:endParaRPr lang="en-US" dirty="0"/>
           </a:p>
@@ -699,7 +697,7 @@
           <a:p>
             <a:r>
               <a:rPr lang="en-US" dirty="0"/>
-              <a:t>Beat 6, slide 1 of 5. Error-handling debt you can describe but not enforce in prose.</a:t>
+              <a:t>Real file 1/5. The headliner.</a:t>
             </a:r>
             <a:endParaRPr lang="en-US" dirty="0"/>
           </a:p>
@@ -787,7 +785,7 @@
           <a:p>
             <a:r>
               <a:rPr lang="en-US" dirty="0"/>
-              <a:t>Beat 6, slide 2 of 5. The leak is proven by graph reachability, not a name heuristic.</a:t>
+              <a:t>Real file 2/5. Design smell, real code.</a:t>
             </a:r>
             <a:endParaRPr lang="en-US" dirty="0"/>
           </a:p>
@@ -875,7 +873,7 @@
           <a:p>
             <a:r>
               <a:rPr lang="en-US" dirty="0"/>
-              <a:t>Beat 6, slide 3 of 5. The flagship flow-sensitivity argument, now on real code.</a:t>
+              <a:t>Real file 3/5. CFG post-dominance over exception edges.</a:t>
             </a:r>
             <a:endParaRPr lang="en-US" dirty="0"/>
           </a:p>
@@ -963,7 +961,7 @@
           <a:p>
             <a:r>
               <a:rPr lang="en-US" dirty="0"/>
-              <a:t>Beat 6, slide 4 of 5. Same dominance primitive, different bug class.</a:t>
+              <a:t>Real file 4/5.</a:t>
             </a:r>
             <a:endParaRPr lang="en-US" dirty="0"/>
           </a:p>
@@ -1051,7 +1049,7 @@
           <a:p>
             <a:r>
               <a:rPr lang="en-US" dirty="0"/>
-              <a:t>Beat 6, slide 5 of 5. Scale: a rulebook says "don't swallow exceptions"; RuleSmith hands you the 15 sites.</a:t>
+              <a:t>Real file 5/5. Ties back to Beat 5 autofix.</a:t>
             </a:r>
             <a:endParaRPr lang="en-US" dirty="0"/>
           </a:p>
@@ -1139,13 +1137,11 @@
           <a:p>
             <a:r>
               <a:rPr lang="en-US" dirty="0"/>
-              <a:t>Close, 30s. The catalog is mined from real authority (not invented). The runtime
-is deterministic. The authoring is AI. One CLI, no key for everyday use.
-Cheat sheet to point at:
-- 10 flow-sensitive rules: examples/java/PaymentGateway.java (12) vs java-fixed (0)
-- Real leak: OneDriveConnectorService.java:516 fileInput (FileInputStream)
-- Filtered FP: IcebergSourceTask.java reader (OffsetStorageReader)
-- Real files: rulesmith lint examples/real-world (5 files, 13-15 rules each)</a:t>
+              <a:t>Close, 30s. The differentiator: the rules that matter are the ones standard tools
+miss, and an English description compiles to one. Cheat sheet:
+- Beat 1: examples/java/PaymentGateway.java (5) vs java-fixed (0)
+- Star real catch: DefaultStrategy.java:69 atomic-get-set-race
+- Others: FtpClientImpl tell-dont-ask/cqs, FtpConnectorService throw-catch, OneDrive leak</a:t>
             </a:r>
             <a:endParaRPr lang="en-US" dirty="0"/>
           </a:p>
@@ -1233,8 +1229,7 @@
           <a:p>
             <a:r>
               <a:rPr lang="en-US" dirty="0"/>
-              <a:t>Beat 0, 45s, no terminal. This is the whole thesis. Land it slowly. The audience
-has all written a CLAUDE.md rulebook; name that reflex, then show why it leaks.</a:t>
+              <a:t>Beat 0, 45s. Set up that the interesting rules are the ones standard tools miss.</a:t>
             </a:r>
             <a:endParaRPr lang="en-US" dirty="0"/>
           </a:p>
@@ -1322,10 +1317,7 @@
           <a:p>
             <a:r>
               <a:rPr lang="en-US" dirty="0"/>
-              <a:t>Beat 1, 110s, the money slide. Read two methods aloud first: the leak with the
-early return, the Optional.get() after a branch. "Would you catch these in review?
-Would a prose rule?" Then run both commands. Punchline: a CLAUDE.md rule sees
-near-identical code in both files and can't tell them apart.</a:t>
+              <a:t>Beat 1, 110s. The money slide. Typestate, lock-dominance, deadlock, purity, closure capture -- all in one screen.</a:t>
             </a:r>
             <a:endParaRPr lang="en-US" dirty="0"/>
           </a:p>
@@ -1413,8 +1405,7 @@
           <a:p>
             <a:r>
               <a:rPr lang="en-US" dirty="0"/>
-              <a:t>Beat 1 continued. Optional slide — skip if short on time. The point: these aren't
-style nits, they're correctness bugs that are invisible to text matching.</a:t>
+              <a:t>Beat 1 continued. This is the slide that answers "isn't this just SonarQube?". No -- these are the ones it misses.</a:t>
             </a:r>
             <a:endParaRPr lang="en-US" dirty="0"/>
           </a:p>
@@ -1502,9 +1493,7 @@
           <a:p>
             <a:r>
               <a:rPr lang="en-US" dirty="0"/>
-              <a:t>Beat 2, 75s. Point at the finding. This is real production code in backend-
-connectors. Stress: every finding cites WHY, and the why is a CFG fact, not a
-language-model opinion.</a:t>
+              <a:t>Beat 2, 75s. The star finding. Real backend-connectors code. Read the textBB line aloud.</a:t>
             </a:r>
             <a:endParaRPr lang="en-US" dirty="0"/>
           </a:p>
@@ -1592,9 +1581,7 @@
           <a:p>
             <a:r>
               <a:rPr lang="en-US" dirty="0"/>
-              <a:t>Beat 3, 90s. This is why you can TRUST an AI-authored rule: it must pass pos/neg
-fixtures before install. Fallback: play the recording if the network stalls.
-113 rules already shipped this way.</a:t>
+              <a:t>Preempts "isn't this just AI linting?". The runtime is deterministic code.</a:t>
             </a:r>
             <a:endParaRPr lang="en-US" dirty="0"/>
           </a:p>
@@ -1682,9 +1669,7 @@
           <a:p>
             <a:r>
               <a:rPr lang="en-US" dirty="0"/>
-              <a:t>This slide preempts the obvious objection: "isn't this just AI linting?" No —
-the runtime is deterministic code. AI is the author and the occasional judge,
-never the everyday engine.</a:t>
+              <a:t>Beat 3, 90s. Trust = the fixture gate. Fallback: play recording.</a:t>
             </a:r>
             <a:endParaRPr lang="en-US" dirty="0"/>
           </a:p>
@@ -1772,9 +1757,7 @@
           <a:p>
             <a:r>
               <a:rPr lang="en-US" dirty="0"/>
-              <a:t>Beat 4, 75s. Name-based heuristic flags OffsetStorageReader; the judge knows it's
-framework-managed and filters it. Cached by (rule, snippet) so the same code
-always gets the same verdict — AI-in-the-loop without losing reproducibility.</a:t>
+              <a:t>Beat 4, 75s. AI-in-the-loop without losing reproducibility.</a:t>
             </a:r>
             <a:endParaRPr lang="en-US" dirty="0"/>
           </a:p>
@@ -1862,8 +1845,7 @@
           <a:p>
             <a:r>
               <a:rPr lang="en-US" dirty="0"/>
-              <a:t>Beat 5, 45s. Same file as Beat 2. The split (2 auto, 1 suggest) shows the tool is
-conservative about rewriting code — it won't corrupt anything it isn't sure of.</a:t>
+              <a:t>Beat 5, 45s. The tool never AI-rewrites code; it won't touch what it can't prove safe.</a:t>
             </a:r>
             <a:endParaRPr lang="en-US" dirty="0"/>
           </a:p>

</xml_diff>